<commit_message>
Teamnamen in Excel-Liste vorbelegt, Bilder komprimiert (Präsentation 361 KB)
Co-Authored-By: Claude Opus 5.5 <noreply@anthropic.com>
Claude-Session: https://claude.ai/code/session_0111joxY9HLNj7w7Z5tgi3FM
</commit_message>
<xml_diff>
--- a/endpraesentation/Elbharz_Endpraesentation.pptx
+++ b/endpraesentation/Elbharz_Endpraesentation.pptx
@@ -119,43 +119,43 @@
   <p:extLst>
     <p:ext uri="{521415D9-36F7-43E2-AB2F-B90AF26B5E84}">
       <p14:sectionLst xmlns:p14="http://schemas.microsoft.com/office/powerpoint/2010/main">
-        <p14:section name="Einleitung" id="{c461b272-78a2-9290-9328-c097d0f9949d}">
+        <p14:section name="Einleitung" id="{68d7ce1f-c253-7e73-4d6f-545ebcce0cda}">
           <p14:sldIdLst>
             <p14:sldId id="256"/>
             <p14:sldId id="257"/>
             <p14:sldId id="258"/>
           </p14:sldIdLst>
         </p14:section>
-        <p14:section name="Verlauf" id="{dfe8e0c7-2735-f458-fc63-4f8506f222ce}">
+        <p14:section name="Verlauf" id="{0c98e0e7-7ef2-7dc9-fe8b-e759d7ff7e96}">
           <p14:sldIdLst>
             <p14:sldId id="259"/>
             <p14:sldId id="260"/>
             <p14:sldId id="261"/>
           </p14:sldIdLst>
         </p14:section>
-        <p14:section name="Auswertung" id="{2d3e4570-774d-f8a8-f573-0fde43656102}">
+        <p14:section name="Auswertung" id="{033d5c48-3250-f338-49de-1da2e7c2a8da}">
           <p14:sldIdLst>
             <p14:sldId id="262"/>
             <p14:sldId id="263"/>
             <p14:sldId id="264"/>
           </p14:sldIdLst>
         </p14:section>
-        <p14:section name="Reflexion" id="{8eabee37-c5f7-4771-c4a7-ca540e84a84e}">
+        <p14:section name="Reflexion" id="{3e99ae92-bc00-1b29-76ee-39302885212e}">
           <p14:sldIdLst>
             <p14:sldId id="265"/>
           </p14:sldIdLst>
         </p14:section>
-        <p14:section name="Gründung" id="{3cee98de-1084-9e2b-9777-869ce5d35641}">
+        <p14:section name="Gründung" id="{5fd58470-59da-acbe-6d3b-e48f86911727}">
           <p14:sldIdLst>
             <p14:sldId id="266"/>
           </p14:sldIdLst>
         </p14:section>
-        <p14:section name="Abschluss" id="{92573ac5-96cb-f0f9-4639-f41a9f8d6c22}">
+        <p14:section name="Abschluss" id="{728d7031-0990-ab39-0c44-29f954076eab}">
           <p14:sldIdLst>
             <p14:sldId id="267"/>
           </p14:sldIdLst>
         </p14:section>
-        <p14:section name="Quellen" id="{750a32a9-e790-f8b6-0146-fc040c42f8d5}">
+        <p14:section name="Quellen" id="{c574f6e5-6f05-fa9b-33a2-193ab2486384}">
           <p14:sldIdLst>
             <p14:sldId id="268"/>
           </p14:sldIdLst>

</xml_diff>